<commit_message>
Add PDF of the presentation; fix slide 11 title and table alignment
</commit_message>
<xml_diff>
--- a/slides/presentation.pptx
+++ b/slides/presentation.pptx
@@ -5841,7 +5841,7 @@
                 </a:solidFill>
                 <a:latin typeface="Cambria"/>
               </a:rPr>
-              <a:t>Crypto carry: weak in-sample, strong since 2024</a:t>
+              <a:t>Crypto carry: weak, then strong since 2024</a:t>
             </a:r>
           </a:p>
         </p:txBody>
@@ -9143,10 +9143,10 @@
                 <a:tableStyleId>{5C22544A-7EE6-4342-B048-85BDC9FD1C3A}</a:tableStyleId>
               </a:tblPr>
               <a:tblGrid>
-                <a:gridCol w="1325880"/>
+                <a:gridCol w="1188720"/>
                 <a:gridCol w="731520"/>
-                <a:gridCol w="777240"/>
-                <a:gridCol w="822960"/>
+                <a:gridCol w="731520"/>
+                <a:gridCol w="1005840"/>
               </a:tblGrid>
               <a:tr h="329184">
                 <a:tc>
@@ -13757,7 +13757,7 @@
                     <a:bodyPr/>
                     <a:lstStyle/>
                     <a:p>
-                      <a:pPr algn="r"/>
+                      <a:pPr algn="l"/>
                       <a:r>
                         <a:rPr sz="1300" b="1">
                           <a:solidFill>
@@ -13780,7 +13780,7 @@
                     <a:bodyPr/>
                     <a:lstStyle/>
                     <a:p>
-                      <a:pPr algn="r"/>
+                      <a:pPr algn="l"/>
                       <a:r>
                         <a:rPr sz="1300" b="1">
                           <a:solidFill>
@@ -13803,7 +13803,7 @@
                     <a:bodyPr/>
                     <a:lstStyle/>
                     <a:p>
-                      <a:pPr algn="r"/>
+                      <a:pPr algn="l"/>
                       <a:r>
                         <a:rPr sz="1300" b="1">
                           <a:solidFill>
@@ -13851,7 +13851,7 @@
                     <a:bodyPr/>
                     <a:lstStyle/>
                     <a:p>
-                      <a:pPr algn="r"/>
+                      <a:pPr algn="l"/>
                       <a:r>
                         <a:rPr sz="1300" b="0">
                           <a:solidFill>
@@ -13874,7 +13874,7 @@
                     <a:bodyPr/>
                     <a:lstStyle/>
                     <a:p>
-                      <a:pPr algn="r"/>
+                      <a:pPr algn="l"/>
                       <a:r>
                         <a:rPr sz="1300" b="0">
                           <a:solidFill>
@@ -13897,7 +13897,7 @@
                     <a:bodyPr/>
                     <a:lstStyle/>
                     <a:p>
-                      <a:pPr algn="r"/>
+                      <a:pPr algn="l"/>
                       <a:r>
                         <a:rPr sz="1300" b="0">
                           <a:solidFill>
@@ -13945,7 +13945,7 @@
                     <a:bodyPr/>
                     <a:lstStyle/>
                     <a:p>
-                      <a:pPr algn="r"/>
+                      <a:pPr algn="l"/>
                       <a:r>
                         <a:rPr sz="1300" b="0">
                           <a:solidFill>
@@ -13968,7 +13968,7 @@
                     <a:bodyPr/>
                     <a:lstStyle/>
                     <a:p>
-                      <a:pPr algn="r"/>
+                      <a:pPr algn="l"/>
                       <a:r>
                         <a:rPr sz="1300" b="0">
                           <a:solidFill>
@@ -13991,7 +13991,7 @@
                     <a:bodyPr/>
                     <a:lstStyle/>
                     <a:p>
-                      <a:pPr algn="r"/>
+                      <a:pPr algn="l"/>
                       <a:r>
                         <a:rPr sz="1300" b="0">
                           <a:solidFill>
@@ -14039,7 +14039,7 @@
                     <a:bodyPr/>
                     <a:lstStyle/>
                     <a:p>
-                      <a:pPr algn="r"/>
+                      <a:pPr algn="l"/>
                       <a:r>
                         <a:rPr sz="1300" b="0">
                           <a:solidFill>
@@ -14062,7 +14062,7 @@
                     <a:bodyPr/>
                     <a:lstStyle/>
                     <a:p>
-                      <a:pPr algn="r"/>
+                      <a:pPr algn="l"/>
                       <a:r>
                         <a:rPr sz="1300" b="0">
                           <a:solidFill>
@@ -14085,7 +14085,7 @@
                     <a:bodyPr/>
                     <a:lstStyle/>
                     <a:p>
-                      <a:pPr algn="r"/>
+                      <a:pPr algn="l"/>
                       <a:r>
                         <a:rPr sz="1300" b="0">
                           <a:solidFill>
@@ -14133,7 +14133,7 @@
                     <a:bodyPr/>
                     <a:lstStyle/>
                     <a:p>
-                      <a:pPr algn="r"/>
+                      <a:pPr algn="l"/>
                       <a:r>
                         <a:rPr sz="1300" b="0">
                           <a:solidFill>
@@ -14156,7 +14156,7 @@
                     <a:bodyPr/>
                     <a:lstStyle/>
                     <a:p>
-                      <a:pPr algn="r"/>
+                      <a:pPr algn="l"/>
                       <a:r>
                         <a:rPr sz="1300" b="0">
                           <a:solidFill>
@@ -14179,7 +14179,7 @@
                     <a:bodyPr/>
                     <a:lstStyle/>
                     <a:p>
-                      <a:pPr algn="r"/>
+                      <a:pPr algn="l"/>
                       <a:r>
                         <a:rPr sz="1300" b="0">
                           <a:solidFill>
@@ -14227,7 +14227,7 @@
                     <a:bodyPr/>
                     <a:lstStyle/>
                     <a:p>
-                      <a:pPr algn="r"/>
+                      <a:pPr algn="l"/>
                       <a:r>
                         <a:rPr sz="1300" b="0">
                           <a:solidFill>
@@ -14250,7 +14250,7 @@
                     <a:bodyPr/>
                     <a:lstStyle/>
                     <a:p>
-                      <a:pPr algn="r"/>
+                      <a:pPr algn="l"/>
                       <a:r>
                         <a:rPr sz="1300" b="0">
                           <a:solidFill>
@@ -14273,7 +14273,7 @@
                     <a:bodyPr/>
                     <a:lstStyle/>
                     <a:p>
-                      <a:pPr algn="r"/>
+                      <a:pPr algn="l"/>
                       <a:r>
                         <a:rPr sz="1300" b="0">
                           <a:solidFill>

</xml_diff>